<commit_message>
Remove word RAG from website titles and PowerPoint presentation slides
</commit_message>
<xml_diff>
--- a/Agentic_HRMS_Platform_Complete_12_Slides.pptx
+++ b/Agentic_HRMS_Platform_Complete_12_Slides.pptx
@@ -3186,7 +3186,7 @@
               </a:defRPr>
             </a:pPr>
             <a:r>
-              <a:t>Enterprise Workforce Intelligence, Predictive Attrition ML, NLP Skill Gap Engine, and RAG HR Policy Assistant</a:t>
+              <a:t>Enterprise Workforce Intelligence, Predictive Attrition ML, NLP Skill Gap Engine, and HR Policy Assistant</a:t>
             </a:r>
           </a:p>
           <a:p>
@@ -3560,7 +3560,7 @@
               </a:defRPr>
             </a:pPr>
             <a:r>
-              <a:t>gemini-flash-latest for grounded RAG policy generation</a:t>
+              <a:t>gemini-flash-latest for grounded policy generation</a:t>
             </a:r>
           </a:p>
         </p:txBody>
@@ -4300,7 +4300,7 @@
               </a:defRPr>
             </a:pPr>
             <a:r>
-              <a:t>• Conclusion: Successfully built and deployed an Agentic HRMS Platform integrating 7 AI engines for proactive attrition risk management, NLP skill gap evaluation, and grounded policy Q&amp;A.</a:t>
+              <a:t>• Conclusion: Successfully built and deployed an Agentic HRMS Platform integrating 7 AI engines for proactive attrition risk management, NLP skill gap evaluation, and policy Q&amp;A.</a:t>
             </a:r>
           </a:p>
           <a:p>
@@ -4552,7 +4552,7 @@
               </a:defRPr>
             </a:pPr>
             <a:r>
-              <a:t>• By integrating Machine Learning classifiers (Random Forest), Sentence Transformer embeddings (all-MiniLM-L6-v2), and Retrieval-Augmented Generation (RAG) with Google Gemini LLM, the system transforms raw HR data into actionable executive decision support.</a:t>
+              <a:t>• By integrating Machine Learning classifiers (Random Forest), Sentence Transformer embeddings (all-MiniLM-L6-v2), and Policy Vector Search with Google Gemini LLM, the system transforms raw HR data into actionable executive decision support.</a:t>
             </a:r>
           </a:p>
         </p:txBody>
@@ -4669,7 +4669,7 @@
               </a:defRPr>
             </a:pPr>
             <a:r>
-              <a:t>• Instant HR Assistance: Provide zero-hallucination answers to complex policy questions 24/7.</a:t>
+              <a:t>• Instant HR Policy Support: Provide accurate answers to complex policy questions 24/7.</a:t>
             </a:r>
           </a:p>
         </p:txBody>
@@ -6426,7 +6426,7 @@
               </a:defRPr>
             </a:pPr>
             <a:r>
-              <a:t>Engine 6: RAG HR Policy Vector Search &amp; LLM Synthesis</a:t>
+              <a:t>Engine 6: HR Policy Vector Search &amp; AI Assistant</a:t>
             </a:r>
           </a:p>
         </p:txBody>
@@ -6483,7 +6483,7 @@
               </a:defRPr>
             </a:pPr>
             <a:r>
-              <a:t>📚 Vector Retrieval Index (12 Corporate Policies)</a:t>
+              <a:t>📚 Policy Vector Index (12 Corporate Policies)</a:t>
             </a:r>
           </a:p>
           <a:p>
@@ -6585,7 +6585,7 @@
               </a:defRPr>
             </a:pPr>
             <a:r>
-              <a:t>🤖 Gemini LLM Grounded Generation</a:t>
+              <a:t>🤖 Gemini LLM Policy Generation</a:t>
             </a:r>
           </a:p>
           <a:p>
@@ -6630,7 +6630,7 @@
               </a:defRPr>
             </a:pPr>
             <a:r>
-              <a:t>• Zero Hallucination Guarantee: If policy info is absent, gracefully declines to answer.</a:t>
+              <a:t>• Accurate Policy Answers: If policy info is absent, gracefully declines to answer.</a:t>
             </a:r>
           </a:p>
         </p:txBody>
@@ -6792,7 +6792,7 @@
               </a:defRPr>
             </a:pPr>
             <a:r>
-              <a:t>• Natural Language Query Processing: Reads raw employee/HR prompt and classifies intent across 6 domain classes.</a:t>
+              <a:t>• Natural Language Query Processing: Reads raw employee/HR prompt and classifies intent across domain classes.</a:t>
             </a:r>
           </a:p>
           <a:p>
@@ -6811,7 +6811,7 @@
             </a:r>
             <a:br/>
             <a:r>
-              <a:t>   - Policy Questions (leave, stipend, insurance) -&gt; Routed to Engine 6 (RAG Policy Q&amp;A)</a:t>
+              <a:t>   - Policy Questions (leave, stipend, insurance) -&gt; Routed to Engine 6 (HR Policy Q&amp;A)</a:t>
             </a:r>
             <a:br/>
             <a:r>

</xml_diff>